<commit_message>
Add demo video link, recorded Sep 30 run, updated deck; fix stale Proving after reload
</commit_message>
<xml_diff>
--- a/docs/deck/Mandate-Wave2-deck.pptx
+++ b/docs/deck/Mandate-Wave2-deck.pptx
@@ -3000,7 +3000,7 @@
                 <a:ea typeface="Courier New" pitchFamily="34" charset="-122"/>
                 <a:cs typeface="Courier New" pitchFamily="34" charset="-120"/>
               </a:rPr>
-              <a:t>5c7f2cc3e8d8bdc554ae3b3e5d65522705341e578c362da2261ab1c70f969757</a:t>
+              <a:t>49ef1c9bec0a0e5e8ab6214184842ea15b6d68c50b6654d12e7ebedfc19d55b9</a:t>
             </a:r>
             <a:endParaRPr lang="en-US" sz="1200" dirty="0"/>
           </a:p>
@@ -3078,7 +3078,7 @@
                 <a:ea typeface="Courier New" pitchFamily="34" charset="-122"/>
                 <a:cs typeface="Courier New" pitchFamily="34" charset="-120"/>
               </a:rPr>
-              <a:t>action 88119 · Lumera block 6,674,184</a:t>
+              <a:t>action 88139 (earlier run: contract 5c7f2cc3…, action 88119)</a:t>
             </a:r>
             <a:endParaRPr lang="en-US" sz="1200" dirty="0"/>
           </a:p>
@@ -5959,7 +5959,7 @@
                 <a:ea typeface="Courier New" pitchFamily="34" charset="-122"/>
                 <a:cs typeface="Courier New" pitchFamily="34" charset="-120"/>
               </a:rPr>
-              <a:t>88119</a:t>
+              <a:t>88139</a:t>
             </a:r>
             <a:endParaRPr lang="en-US" sz="2600" dirty="0"/>
           </a:p>
@@ -5998,7 +5998,7 @@
                 <a:ea typeface="Arial" pitchFamily="34" charset="-122"/>
                 <a:cs typeface="Arial" pitchFamily="34" charset="-120"/>
               </a:rPr>
-              <a:t>Cascade action</a:t>
+              <a:t>Cascade action, recorded run (Sep 30)</a:t>
             </a:r>
             <a:endParaRPr lang="en-US" sz="1100" dirty="0"/>
           </a:p>
@@ -6062,7 +6062,7 @@
                 <a:ea typeface="Courier New" pitchFamily="34" charset="-122"/>
                 <a:cs typeface="Courier New" pitchFamily="34" charset="-120"/>
               </a:rPr>
-              <a:t>6,674,184</a:t>
+              <a:t>88119</a:t>
             </a:r>
             <a:endParaRPr lang="en-US" sz="2600" dirty="0"/>
           </a:p>
@@ -6101,7 +6101,7 @@
                 <a:ea typeface="Arial" pitchFamily="34" charset="-122"/>
                 <a:cs typeface="Arial" pitchFamily="34" charset="-120"/>
               </a:rPr>
-              <a:t>Lumera block</a:t>
+              <a:t>Cascade action, earlier run (Sep 17)</a:t>
             </a:r>
             <a:endParaRPr lang="en-US" sz="1100" dirty="0"/>
           </a:p>
@@ -6757,7 +6757,7 @@
                 <a:ea typeface="Courier New" pitchFamily="34" charset="-122"/>
                 <a:cs typeface="Courier New" pitchFamily="34" charset="-120"/>
               </a:rPr>
-              <a:t>5c7f2cc3e8d8bdc5…b1c70f969757</a:t>
+              <a:t>49ef1c9bec0a…c19d55b9</a:t>
             </a:r>
             <a:endParaRPr lang="en-US" sz="1200" dirty="0"/>
           </a:p>

</xml_diff>